<commit_message>
Add senior B femenino (red/white editorial) and perfect Supercopa senior A masc
- Senior B femenino: variant with Roig Barna background + white giant
  surname (pairs with the cream+red masculino version)
- Supercopa Senior A masculi: editorial-light cartel with court texture,
  giant red SUPER/COPA behind the player cutout, name + footer (4:5 deck)
- cataleg-formats.md updated with both variants and the two senior A
  treatments (dark epic vs light editorial)

Co-Authored-By: Claude Fable 5 <noreply@anthropic.com>
Claude-Session: https://claude.ai/code/session_019nqn6YbVc87JKLByoDNLSH
</commit_message>
<xml_diff>
--- a/.claude/skills/portada-velo-cbgb/assets/Carrusel_CBGB_4x5.pptx
+++ b/.claude/skills/portada-velo-cbgb/assets/Carrusel_CBGB_4x5.pptx
@@ -7,9 +7,10 @@
   <p:sldIdLst>
     <p:sldId id="256" r:id="rId2"/>
     <p:sldId id="257" r:id="rId3"/>
+    <p:sldId id="258" r:id="rId4"/>
   </p:sldIdLst>
   <p:notesMasterIdLst>
-    <p:notesMasterId r:id="rId4"/>
+    <p:notesMasterId r:id="rId5"/>
   </p:notesMasterIdLst>
   <p:sldSz cx="5486400" cy="6858000"/>
   <p:notesSz cx="6858000" cy="5486400"/>
@@ -633,6 +634,94 @@
 </p:notes>
 </file>
 
+<file path=ppt/notesSlides/notesSlide3.xml><?xml version="1.0" encoding="utf-8"?>
+<p:notes xmlns:a="http://schemas.openxmlformats.org/drawingml/2006/main" xmlns:r="http://schemas.openxmlformats.org/officeDocument/2006/relationships" xmlns:p="http://schemas.openxmlformats.org/presentationml/2006/main">
+  <p:cSld>
+    <p:spTree>
+      <p:nvGrpSpPr>
+        <p:cNvPr id="1" name=""/>
+        <p:cNvGrpSpPr/>
+        <p:nvPr/>
+      </p:nvGrpSpPr>
+      <p:grpSpPr>
+        <a:xfrm>
+          <a:off x="0" y="0"/>
+          <a:ext cx="0" cy="0"/>
+          <a:chOff x="0" y="0"/>
+          <a:chExt cx="0" cy="0"/>
+        </a:xfrm>
+      </p:grpSpPr>
+      <p:sp>
+        <p:nvSpPr>
+          <p:cNvPr id="2" name="Slide Image Placeholder 1"/>
+          <p:cNvSpPr>
+            <a:spLocks noGrp="1" noRot="1" noChangeAspect="1"/>
+          </p:cNvSpPr>
+          <p:nvPr>
+            <p:ph type="sldImg"/>
+          </p:nvPr>
+        </p:nvSpPr>
+        <p:spPr/>
+      </p:sp>
+      <p:sp>
+        <p:nvSpPr>
+          <p:cNvPr id="3" name="Notes Placeholder 2"/>
+          <p:cNvSpPr>
+            <a:spLocks noGrp="1"/>
+          </p:cNvSpPr>
+          <p:nvPr>
+            <p:ph type="body" idx="1"/>
+          </p:nvPr>
+        </p:nvSpPr>
+        <p:spPr/>
+        <p:txBody>
+          <a:bodyPr/>
+          <a:lstStyle/>
+          <a:p>
+            <a:r>
+              <a:rPr lang="en-US" dirty="0"/>
+              <a:t/>
+            </a:r>
+            <a:endParaRPr lang="en-US" dirty="0"/>
+          </a:p>
+        </p:txBody>
+      </p:sp>
+      <p:sp>
+        <p:nvSpPr>
+          <p:cNvPr id="4" name="Slide Number Placeholder 3"/>
+          <p:cNvSpPr>
+            <a:spLocks noGrp="1"/>
+          </p:cNvSpPr>
+          <p:nvPr>
+            <p:ph type="sldNum" sz="quarter" idx="10"/>
+          </p:nvPr>
+        </p:nvSpPr>
+        <p:spPr/>
+        <p:txBody>
+          <a:bodyPr/>
+          <a:lstStyle/>
+          <a:p>
+            <a:fld id="{F7021451-1387-4CA6-816F-3879F97B5CBC}" type="slidenum">
+              <a:rPr lang="en-US"/>
+              <a:t>3</a:t>
+            </a:fld>
+            <a:endParaRPr lang="en-US"/>
+          </a:p>
+        </p:txBody>
+      </p:sp>
+    </p:spTree>
+    <p:extLst>
+      <p:ext uri="{BB962C8B-B14F-4D97-AF65-F5344CB8AC3E}">
+        <p14:creationId xmlns:p14="http://schemas.microsoft.com/office/powerpoint/2010/main" val="1024086991"/>
+      </p:ext>
+    </p:extLst>
+  </p:cSld>
+  <p:clrMapOvr>
+    <a:masterClrMapping/>
+  </p:clrMapOvr>
+</p:notes>
+</file>
+
 <file path=ppt/slideLayouts/slideLayout1.xml><?xml version="1.0" encoding="utf-8"?>
 <p:sldLayout xmlns:a="http://schemas.openxmlformats.org/drawingml/2006/main" xmlns:r="http://schemas.openxmlformats.org/officeDocument/2006/relationships" xmlns:p="http://schemas.openxmlformats.org/presentationml/2006/main" preserve="1">
   <p:cSld name="DEFAULT">
@@ -1647,6 +1736,434 @@
               <a:t>→</a:t>
             </a:r>
             <a:endParaRPr lang="en-US" sz="1920" dirty="0"/>
+          </a:p>
+        </p:txBody>
+      </p:sp>
+    </p:spTree>
+  </p:cSld>
+  <p:clrMapOvr>
+    <a:masterClrMapping/>
+  </p:clrMapOvr>
+</p:sld>
+</file>
+
+<file path=ppt/slides/slide3.xml><?xml version="1.0" encoding="utf-8"?>
+<p:sld xmlns:a="http://schemas.openxmlformats.org/drawingml/2006/main" xmlns:r="http://schemas.openxmlformats.org/officeDocument/2006/relationships" xmlns:p="http://schemas.openxmlformats.org/presentationml/2006/main">
+  <p:cSld name="Slide 3">
+    <p:bg>
+      <p:bgPr>
+        <a:blipFill dpi="0" rotWithShape="1">
+          <a:blip r:embed="rId1">
+            <a:lum/>
+          </a:blip>
+          <a:srcRect/>
+          <a:stretch>
+            <a:fillRect/>
+          </a:stretch>
+        </a:blipFill>
+        <a:effectLst/>
+      </p:bgPr>
+    </p:bg>
+    <p:spTree>
+      <p:nvGrpSpPr>
+        <p:cNvPr id="1" name=""/>
+        <p:cNvGrpSpPr/>
+        <p:nvPr/>
+      </p:nvGrpSpPr>
+      <p:grpSpPr>
+        <a:xfrm>
+          <a:off x="0" y="0"/>
+          <a:ext cx="0" cy="0"/>
+          <a:chOff x="0" y="0"/>
+          <a:chExt cx="0" cy="0"/>
+        </a:xfrm>
+      </p:grpSpPr>
+      <p:sp>
+        <p:nvSpPr>
+          <p:cNvPr id="2" name="Text 0"/>
+          <p:cNvSpPr/>
+          <p:nvPr/>
+        </p:nvSpPr>
+        <p:spPr>
+          <a:xfrm>
+            <a:off x="355600" y="762000"/>
+            <a:ext cx="4775200" cy="355600"/>
+          </a:xfrm>
+          <a:prstGeom prst="rect">
+            <a:avLst/>
+          </a:prstGeom>
+          <a:noFill/>
+          <a:ln/>
+        </p:spPr>
+        <p:txBody>
+          <a:bodyPr wrap="square" lIns="0" tIns="0" rIns="0" bIns="0" rtlCol="0" anchor="ctr"/>
+          <a:lstStyle/>
+          <a:p>
+            <a:pPr algn="ctr" indent="0" marL="0">
+              <a:buNone/>
+            </a:pPr>
+            <a:r>
+              <a:rPr lang="en-US" sz="2560" spc="800" kern="0" dirty="0">
+                <a:solidFill>
+                  <a:srgbClr val="0A0A0C"/>
+                </a:solidFill>
+                <a:latin typeface="Bebas Neue" pitchFamily="34" charset="0"/>
+                <a:ea typeface="Bebas Neue" pitchFamily="34" charset="-122"/>
+                <a:cs typeface="Bebas Neue" pitchFamily="34" charset="-120"/>
+              </a:rPr>
+              <a:t>SÈNIOR A MASCULÍ</a:t>
+            </a:r>
+            <a:endParaRPr lang="en-US" sz="2560" dirty="0"/>
+          </a:p>
+        </p:txBody>
+      </p:sp>
+      <p:sp>
+        <p:nvSpPr>
+          <p:cNvPr id="3" name="Text 1"/>
+          <p:cNvSpPr/>
+          <p:nvPr/>
+        </p:nvSpPr>
+        <p:spPr>
+          <a:xfrm>
+            <a:off x="355600" y="457200"/>
+            <a:ext cx="4775200" cy="254000"/>
+          </a:xfrm>
+          <a:prstGeom prst="rect">
+            <a:avLst/>
+          </a:prstGeom>
+          <a:noFill/>
+          <a:ln/>
+        </p:spPr>
+        <p:txBody>
+          <a:bodyPr wrap="square" lIns="0" tIns="0" rIns="0" bIns="0" rtlCol="0" anchor="ctr"/>
+          <a:lstStyle/>
+          <a:p>
+            <a:pPr algn="ctr" indent="0" marL="0">
+              <a:buNone/>
+            </a:pPr>
+            <a:r>
+              <a:rPr lang="en-US" sz="1040" b="1" spc="600" kern="0" dirty="0">
+                <a:solidFill>
+                  <a:srgbClr val="55555A"/>
+                </a:solidFill>
+                <a:latin typeface="Montserrat" pitchFamily="34" charset="0"/>
+                <a:ea typeface="Montserrat" pitchFamily="34" charset="-122"/>
+                <a:cs typeface="Montserrat" pitchFamily="34" charset="-120"/>
+              </a:rPr>
+              <a:t>TEMPORADA 26·27</a:t>
+            </a:r>
+            <a:endParaRPr lang="en-US" sz="1040" dirty="0"/>
+          </a:p>
+        </p:txBody>
+      </p:sp>
+      <p:pic>
+        <p:nvPicPr>
+          <p:cNvPr id="4" name="Image 0" descr="img/escut.png">    </p:cNvPr>
+          <p:cNvPicPr>
+            <a:picLocks noChangeAspect="1"/>
+          </p:cNvPicPr>
+          <p:nvPr/>
+        </p:nvPicPr>
+        <p:blipFill>
+          <a:blip r:embed="rId2"/>
+          <a:stretch>
+            <a:fillRect/>
+          </a:stretch>
+        </p:blipFill>
+        <p:spPr>
+          <a:xfrm>
+            <a:off x="4647387" y="355600"/>
+            <a:ext cx="483413" cy="660400"/>
+          </a:xfrm>
+          <a:prstGeom prst="rect">
+            <a:avLst/>
+          </a:prstGeom>
+        </p:spPr>
+      </p:pic>
+      <p:sp>
+        <p:nvSpPr>
+          <p:cNvPr id="5" name="Text 2"/>
+          <p:cNvSpPr/>
+          <p:nvPr/>
+        </p:nvSpPr>
+        <p:spPr>
+          <a:xfrm>
+            <a:off x="4470400" y="355600"/>
+            <a:ext cx="304800" cy="254000"/>
+          </a:xfrm>
+          <a:prstGeom prst="rect">
+            <a:avLst/>
+          </a:prstGeom>
+          <a:solidFill>
+            <a:srgbClr val="222225"/>
+          </a:solidFill>
+          <a:ln/>
+        </p:spPr>
+        <p:txBody>
+          <a:bodyPr wrap="square" lIns="0" tIns="0" rIns="0" bIns="0" rtlCol="0" anchor="ctr"/>
+          <a:lstStyle/>
+          <a:p>
+            <a:pPr algn="ctr" indent="0" marL="0">
+              <a:buNone/>
+            </a:pPr>
+            <a:r>
+              <a:rPr lang="en-US" sz="1040" b="1" dirty="0">
+                <a:solidFill>
+                  <a:srgbClr val="FFFFFF"/>
+                </a:solidFill>
+                <a:latin typeface="Montserrat" pitchFamily="34" charset="0"/>
+                <a:ea typeface="Montserrat" pitchFamily="34" charset="-122"/>
+                <a:cs typeface="Montserrat" pitchFamily="34" charset="-120"/>
+              </a:rPr>
+              <a:t>1/6</a:t>
+            </a:r>
+            <a:endParaRPr lang="en-US" sz="1040" dirty="0"/>
+          </a:p>
+        </p:txBody>
+      </p:sp>
+      <p:sp>
+        <p:nvSpPr>
+          <p:cNvPr id="6" name="Text 3"/>
+          <p:cNvSpPr/>
+          <p:nvPr/>
+        </p:nvSpPr>
+        <p:spPr>
+          <a:xfrm>
+            <a:off x="-50800" y="1168400"/>
+            <a:ext cx="3657600" cy="2184400"/>
+          </a:xfrm>
+          <a:prstGeom prst="rect">
+            <a:avLst/>
+          </a:prstGeom>
+          <a:noFill/>
+          <a:ln/>
+        </p:spPr>
+        <p:txBody>
+          <a:bodyPr wrap="square" lIns="0" tIns="0" rIns="0" bIns="0" rtlCol="0" anchor="t"/>
+          <a:lstStyle/>
+          <a:p>
+            <a:pPr algn="l" indent="0" marL="0">
+              <a:buNone/>
+            </a:pPr>
+            <a:r>
+              <a:rPr lang="en-US" sz="14400" dirty="0">
+                <a:solidFill>
+                  <a:srgbClr val="E31E24"/>
+                </a:solidFill>
+                <a:latin typeface="Bebas Neue" pitchFamily="34" charset="0"/>
+                <a:ea typeface="Bebas Neue" pitchFamily="34" charset="-122"/>
+                <a:cs typeface="Bebas Neue" pitchFamily="34" charset="-120"/>
+              </a:rPr>
+              <a:t>SUPER</a:t>
+            </a:r>
+            <a:endParaRPr lang="en-US" sz="14400" dirty="0"/>
+          </a:p>
+        </p:txBody>
+      </p:sp>
+      <p:sp>
+        <p:nvSpPr>
+          <p:cNvPr id="7" name="Text 4"/>
+          <p:cNvSpPr/>
+          <p:nvPr/>
+        </p:nvSpPr>
+        <p:spPr>
+          <a:xfrm>
+            <a:off x="-50800" y="3251200"/>
+            <a:ext cx="3657600" cy="2184400"/>
+          </a:xfrm>
+          <a:prstGeom prst="rect">
+            <a:avLst/>
+          </a:prstGeom>
+          <a:noFill/>
+          <a:ln/>
+        </p:spPr>
+        <p:txBody>
+          <a:bodyPr wrap="square" lIns="0" tIns="0" rIns="0" bIns="0" rtlCol="0" anchor="t"/>
+          <a:lstStyle/>
+          <a:p>
+            <a:pPr algn="l" indent="0" marL="0">
+              <a:buNone/>
+            </a:pPr>
+            <a:r>
+              <a:rPr lang="en-US" sz="14400" dirty="0">
+                <a:solidFill>
+                  <a:srgbClr val="E31E24"/>
+                </a:solidFill>
+                <a:latin typeface="Bebas Neue" pitchFamily="34" charset="0"/>
+                <a:ea typeface="Bebas Neue" pitchFamily="34" charset="-122"/>
+                <a:cs typeface="Bebas Neue" pitchFamily="34" charset="-120"/>
+              </a:rPr>
+              <a:t>COPA</a:t>
+            </a:r>
+            <a:endParaRPr lang="en-US" sz="14400" dirty="0"/>
+          </a:p>
+        </p:txBody>
+      </p:sp>
+      <p:sp>
+        <p:nvSpPr>
+          <p:cNvPr id="8" name="Shape 5"/>
+          <p:cNvSpPr/>
+          <p:nvPr/>
+        </p:nvSpPr>
+        <p:spPr>
+          <a:xfrm>
+            <a:off x="1828800" y="1524000"/>
+            <a:ext cx="3149600" cy="4572000"/>
+          </a:xfrm>
+          <a:prstGeom prst="rect">
+            <a:avLst/>
+          </a:prstGeom>
+          <a:solidFill>
+            <a:srgbClr val="000000">
+              <a:alpha val="30000"/>
+            </a:srgbClr>
+          </a:solidFill>
+          <a:ln w="19050">
+            <a:solidFill>
+              <a:srgbClr val="999999"/>
+            </a:solidFill>
+            <a:prstDash val="dash"/>
+          </a:ln>
+        </p:spPr>
+      </p:sp>
+      <p:sp>
+        <p:nvSpPr>
+          <p:cNvPr id="9" name="Text 6"/>
+          <p:cNvSpPr/>
+          <p:nvPr/>
+        </p:nvSpPr>
+        <p:spPr>
+          <a:xfrm>
+            <a:off x="1828800" y="1524000"/>
+            <a:ext cx="3149600" cy="4572000"/>
+          </a:xfrm>
+          <a:prstGeom prst="rect">
+            <a:avLst/>
+          </a:prstGeom>
+          <a:noFill/>
+          <a:ln/>
+        </p:spPr>
+        <p:txBody>
+          <a:bodyPr wrap="square" lIns="1411" tIns="1411" rIns="1411" bIns="1411" rtlCol="0" anchor="ctr"/>
+          <a:lstStyle/>
+          <a:p>
+            <a:pPr algn="ctr" indent="0" marL="0">
+              <a:buNone/>
+            </a:pPr>
+            <a:r>
+              <a:rPr lang="en-US" sz="1200" dirty="0">
+                <a:solidFill>
+                  <a:srgbClr val="999999"/>
+                </a:solidFill>
+                <a:latin typeface="Montserrat" pitchFamily="34" charset="0"/>
+                <a:ea typeface="Montserrat" pitchFamily="34" charset="-122"/>
+                <a:cs typeface="Montserrat" pitchFamily="34" charset="-120"/>
+              </a:rPr>
+              <a:t>▶ Retall jugador (PNG sense fons) DAVANT de SUPERCOPA</a:t>
+            </a:r>
+            <a:endParaRPr lang="en-US" sz="1200" dirty="0"/>
+          </a:p>
+        </p:txBody>
+      </p:sp>
+      <p:sp>
+        <p:nvSpPr>
+          <p:cNvPr id="10" name="Text 7"/>
+          <p:cNvSpPr/>
+          <p:nvPr/>
+        </p:nvSpPr>
+        <p:spPr>
+          <a:xfrm>
+            <a:off x="355600" y="5689600"/>
+            <a:ext cx="4775200" cy="1016000"/>
+          </a:xfrm>
+          <a:prstGeom prst="rect">
+            <a:avLst/>
+          </a:prstGeom>
+          <a:noFill/>
+          <a:ln/>
+        </p:spPr>
+        <p:txBody>
+          <a:bodyPr wrap="square" lIns="0" tIns="0" rIns="0" bIns="0" rtlCol="0" anchor="ctr"/>
+          <a:lstStyle/>
+          <a:p>
+            <a:pPr algn="ctr" indent="0" marL="0">
+              <a:lnSpc>
+                <a:spcPct val="92000"/>
+              </a:lnSpc>
+              <a:buNone/>
+            </a:pPr>
+            <a:r>
+              <a:rPr lang="en-US" sz="3840" dirty="0">
+                <a:solidFill>
+                  <a:srgbClr val="E31E24"/>
+                </a:solidFill>
+                <a:latin typeface="Bebas Neue" pitchFamily="34" charset="0"/>
+                <a:ea typeface="Bebas Neue" pitchFamily="34" charset="-122"/>
+                <a:cs typeface="Bebas Neue" pitchFamily="34" charset="-120"/>
+              </a:rPr>
+              <a:t>CARLOS
+</a:t>
+            </a:r>
+            <a:endParaRPr lang="en-US" sz="3840" dirty="0"/>
+          </a:p>
+          <a:p>
+            <a:pPr algn="ctr" indent="0" marL="0">
+              <a:lnSpc>
+                <a:spcPct val="92000"/>
+              </a:lnSpc>
+              <a:buNone/>
+            </a:pPr>
+            <a:r>
+              <a:rPr lang="en-US" sz="2560" dirty="0">
+                <a:solidFill>
+                  <a:srgbClr val="0A0A0C"/>
+                </a:solidFill>
+                <a:latin typeface="Bebas Neue" pitchFamily="34" charset="0"/>
+                <a:ea typeface="Bebas Neue" pitchFamily="34" charset="-122"/>
+                <a:cs typeface="Bebas Neue" pitchFamily="34" charset="-120"/>
+              </a:rPr>
+              <a:t>RODRÍGUEZ DE LA HERA</a:t>
+            </a:r>
+            <a:endParaRPr lang="en-US" sz="3840" dirty="0"/>
+          </a:p>
+        </p:txBody>
+      </p:sp>
+      <p:sp>
+        <p:nvSpPr>
+          <p:cNvPr id="11" name="Text 8"/>
+          <p:cNvSpPr/>
+          <p:nvPr/>
+        </p:nvSpPr>
+        <p:spPr>
+          <a:xfrm>
+            <a:off x="355600" y="6553200"/>
+            <a:ext cx="4775200" cy="223520"/>
+          </a:xfrm>
+          <a:prstGeom prst="rect">
+            <a:avLst/>
+          </a:prstGeom>
+          <a:noFill/>
+          <a:ln/>
+        </p:spPr>
+        <p:txBody>
+          <a:bodyPr wrap="square" lIns="0" tIns="0" rIns="0" bIns="0" rtlCol="0" anchor="ctr"/>
+          <a:lstStyle/>
+          <a:p>
+            <a:pPr algn="ctr" indent="0" marL="0">
+              <a:buNone/>
+            </a:pPr>
+            <a:r>
+              <a:rPr lang="en-US" sz="960" b="1" spc="300" kern="0" dirty="0">
+                <a:solidFill>
+                  <a:srgbClr val="55555A"/>
+                </a:solidFill>
+                <a:latin typeface="Montserrat" pitchFamily="34" charset="0"/>
+                <a:ea typeface="Montserrat" pitchFamily="34" charset="-122"/>
+                <a:cs typeface="Montserrat" pitchFamily="34" charset="-120"/>
+              </a:rPr>
+              <a:t>FORMAT AL BARNA · NOU FITXATGE 26/27</a:t>
+            </a:r>
+            <a:endParaRPr lang="en-US" sz="960" dirty="0"/>
           </a:p>
         </p:txBody>
       </p:sp>

</xml_diff>

<commit_message>
Add premium 'ÉS BARNA' fitxatge cartel (replica of Barça 'és culer')
- New cinematic template replicating the MARTIN·ÉS CULER poster: full-bleed
  dark photo with red/blue rim light, gold serif type on one line with the
  escut centered between name and 'ÉS BARNA', discreet gold footer
- Added to both decks (4:5 feed + 9:16 story) as 'FITXATGE · ÉS BARNA'
- New cinematic backgrounds generated (bg_esculer 4:5 and 9:16)
- cataleg-formats.md: documented format 4b, the club's only serif+gold piece,
  reserved for premium signings ('és culer' → 'és barna' adaptation)

Co-Authored-By: Claude Fable 5 <noreply@anthropic.com>
Claude-Session: https://claude.ai/code/session_019nqn6YbVc87JKLByoDNLSH
</commit_message>
<xml_diff>
--- a/.claude/skills/portada-velo-cbgb/assets/Carrusel_CBGB_4x5.pptx
+++ b/.claude/skills/portada-velo-cbgb/assets/Carrusel_CBGB_4x5.pptx
@@ -8,9 +8,10 @@
     <p:sldId id="256" r:id="rId2"/>
     <p:sldId id="257" r:id="rId3"/>
     <p:sldId id="258" r:id="rId4"/>
+    <p:sldId id="259" r:id="rId5"/>
   </p:sldIdLst>
   <p:notesMasterIdLst>
-    <p:notesMasterId r:id="rId5"/>
+    <p:notesMasterId r:id="rId6"/>
   </p:notesMasterIdLst>
   <p:sldSz cx="5486400" cy="6858000"/>
   <p:notesSz cx="6858000" cy="5486400"/>
@@ -722,6 +723,94 @@
 </p:notes>
 </file>
 
+<file path=ppt/notesSlides/notesSlide4.xml><?xml version="1.0" encoding="utf-8"?>
+<p:notes xmlns:a="http://schemas.openxmlformats.org/drawingml/2006/main" xmlns:r="http://schemas.openxmlformats.org/officeDocument/2006/relationships" xmlns:p="http://schemas.openxmlformats.org/presentationml/2006/main">
+  <p:cSld>
+    <p:spTree>
+      <p:nvGrpSpPr>
+        <p:cNvPr id="1" name=""/>
+        <p:cNvGrpSpPr/>
+        <p:nvPr/>
+      </p:nvGrpSpPr>
+      <p:grpSpPr>
+        <a:xfrm>
+          <a:off x="0" y="0"/>
+          <a:ext cx="0" cy="0"/>
+          <a:chOff x="0" y="0"/>
+          <a:chExt cx="0" cy="0"/>
+        </a:xfrm>
+      </p:grpSpPr>
+      <p:sp>
+        <p:nvSpPr>
+          <p:cNvPr id="2" name="Slide Image Placeholder 1"/>
+          <p:cNvSpPr>
+            <a:spLocks noGrp="1" noRot="1" noChangeAspect="1"/>
+          </p:cNvSpPr>
+          <p:nvPr>
+            <p:ph type="sldImg"/>
+          </p:nvPr>
+        </p:nvSpPr>
+        <p:spPr/>
+      </p:sp>
+      <p:sp>
+        <p:nvSpPr>
+          <p:cNvPr id="3" name="Notes Placeholder 2"/>
+          <p:cNvSpPr>
+            <a:spLocks noGrp="1"/>
+          </p:cNvSpPr>
+          <p:nvPr>
+            <p:ph type="body" idx="1"/>
+          </p:nvPr>
+        </p:nvSpPr>
+        <p:spPr/>
+        <p:txBody>
+          <a:bodyPr/>
+          <a:lstStyle/>
+          <a:p>
+            <a:r>
+              <a:rPr lang="en-US" dirty="0"/>
+              <a:t/>
+            </a:r>
+            <a:endParaRPr lang="en-US" dirty="0"/>
+          </a:p>
+        </p:txBody>
+      </p:sp>
+      <p:sp>
+        <p:nvSpPr>
+          <p:cNvPr id="4" name="Slide Number Placeholder 3"/>
+          <p:cNvSpPr>
+            <a:spLocks noGrp="1"/>
+          </p:cNvSpPr>
+          <p:nvPr>
+            <p:ph type="sldNum" sz="quarter" idx="10"/>
+          </p:nvPr>
+        </p:nvSpPr>
+        <p:spPr/>
+        <p:txBody>
+          <a:bodyPr/>
+          <a:lstStyle/>
+          <a:p>
+            <a:fld id="{F7021451-1387-4CA6-816F-3879F97B5CBC}" type="slidenum">
+              <a:rPr lang="en-US"/>
+              <a:t>4</a:t>
+            </a:fld>
+            <a:endParaRPr lang="en-US"/>
+          </a:p>
+        </p:txBody>
+      </p:sp>
+    </p:spTree>
+    <p:extLst>
+      <p:ext uri="{BB962C8B-B14F-4D97-AF65-F5344CB8AC3E}">
+        <p14:creationId xmlns:p14="http://schemas.microsoft.com/office/powerpoint/2010/main" val="1024086991"/>
+      </p:ext>
+    </p:extLst>
+  </p:cSld>
+  <p:clrMapOvr>
+    <a:masterClrMapping/>
+  </p:clrMapOvr>
+</p:notes>
+</file>
+
 <file path=ppt/slideLayouts/slideLayout1.xml><?xml version="1.0" encoding="utf-8"?>
 <p:sldLayout xmlns:a="http://schemas.openxmlformats.org/drawingml/2006/main" xmlns:r="http://schemas.openxmlformats.org/officeDocument/2006/relationships" xmlns:p="http://schemas.openxmlformats.org/presentationml/2006/main" preserve="1">
   <p:cSld name="DEFAULT">
@@ -2162,6 +2251,225 @@
                 <a:cs typeface="Montserrat" pitchFamily="34" charset="-120"/>
               </a:rPr>
               <a:t>FORMAT AL BARNA · NOU FITXATGE 26/27</a:t>
+            </a:r>
+            <a:endParaRPr lang="en-US" sz="960" dirty="0"/>
+          </a:p>
+        </p:txBody>
+      </p:sp>
+    </p:spTree>
+  </p:cSld>
+  <p:clrMapOvr>
+    <a:masterClrMapping/>
+  </p:clrMapOvr>
+</p:sld>
+</file>
+
+<file path=ppt/slides/slide4.xml><?xml version="1.0" encoding="utf-8"?>
+<p:sld xmlns:a="http://schemas.openxmlformats.org/drawingml/2006/main" xmlns:r="http://schemas.openxmlformats.org/officeDocument/2006/relationships" xmlns:p="http://schemas.openxmlformats.org/presentationml/2006/main">
+  <p:cSld name="Slide 4">
+    <p:bg>
+      <p:bgPr>
+        <a:blipFill dpi="0" rotWithShape="1">
+          <a:blip r:embed="rId1">
+            <a:lum/>
+          </a:blip>
+          <a:srcRect/>
+          <a:stretch>
+            <a:fillRect/>
+          </a:stretch>
+        </a:blipFill>
+        <a:effectLst/>
+      </p:bgPr>
+    </p:bg>
+    <p:spTree>
+      <p:nvGrpSpPr>
+        <p:cNvPr id="1" name=""/>
+        <p:cNvGrpSpPr/>
+        <p:nvPr/>
+      </p:nvGrpSpPr>
+      <p:grpSpPr>
+        <a:xfrm>
+          <a:off x="0" y="0"/>
+          <a:ext cx="0" cy="0"/>
+          <a:chOff x="0" y="0"/>
+          <a:chExt cx="0" cy="0"/>
+        </a:xfrm>
+      </p:grpSpPr>
+      <p:sp>
+        <p:nvSpPr>
+          <p:cNvPr id="2" name="Text 0"/>
+          <p:cNvSpPr/>
+          <p:nvPr/>
+        </p:nvSpPr>
+        <p:spPr>
+          <a:xfrm>
+            <a:off x="609600" y="660400"/>
+            <a:ext cx="4267200" cy="284480"/>
+          </a:xfrm>
+          <a:prstGeom prst="rect">
+            <a:avLst/>
+          </a:prstGeom>
+          <a:noFill/>
+          <a:ln/>
+        </p:spPr>
+        <p:txBody>
+          <a:bodyPr wrap="square" lIns="0" tIns="0" rIns="0" bIns="0" rtlCol="0" anchor="ctr"/>
+          <a:lstStyle/>
+          <a:p>
+            <a:pPr algn="ctr" indent="0" marL="0">
+              <a:buNone/>
+            </a:pPr>
+            <a:r>
+              <a:rPr lang="en-US" sz="960" dirty="0">
+                <a:solidFill>
+                  <a:srgbClr val="6A6A70"/>
+                </a:solidFill>
+                <a:latin typeface="Montserrat" pitchFamily="34" charset="0"/>
+                <a:ea typeface="Montserrat" pitchFamily="34" charset="-122"/>
+                <a:cs typeface="Montserrat" pitchFamily="34" charset="-120"/>
+              </a:rPr>
+              <a:t>▶ Substitueix el fons per la FOTO del fitxatge (retall a sang, mirada a càmera, llum lateral)</a:t>
+            </a:r>
+            <a:endParaRPr lang="en-US" sz="960" dirty="0"/>
+          </a:p>
+        </p:txBody>
+      </p:sp>
+      <p:sp>
+        <p:nvSpPr>
+          <p:cNvPr id="3" name="Text 1"/>
+          <p:cNvSpPr/>
+          <p:nvPr/>
+        </p:nvSpPr>
+        <p:spPr>
+          <a:xfrm>
+            <a:off x="152400" y="3505200"/>
+            <a:ext cx="2235200" cy="965200"/>
+          </a:xfrm>
+          <a:prstGeom prst="rect">
+            <a:avLst/>
+          </a:prstGeom>
+          <a:noFill/>
+          <a:ln/>
+        </p:spPr>
+        <p:txBody>
+          <a:bodyPr wrap="square" lIns="0" tIns="0" rIns="0" bIns="0" rtlCol="0" anchor="ctr"/>
+          <a:lstStyle/>
+          <a:p>
+            <a:pPr algn="r" indent="0" marL="0">
+              <a:buNone/>
+            </a:pPr>
+            <a:r>
+              <a:rPr lang="en-US" sz="2880" b="1" spc="300" kern="0" dirty="0">
+                <a:solidFill>
+                  <a:srgbClr val="C7A24C"/>
+                </a:solidFill>
+                <a:latin typeface="Georgia" pitchFamily="34" charset="0"/>
+                <a:ea typeface="Georgia" pitchFamily="34" charset="-122"/>
+                <a:cs typeface="Georgia" pitchFamily="34" charset="-120"/>
+              </a:rPr>
+              <a:t>MARTIN</a:t>
+            </a:r>
+            <a:endParaRPr lang="en-US" sz="2880" dirty="0"/>
+          </a:p>
+        </p:txBody>
+      </p:sp>
+      <p:pic>
+        <p:nvPicPr>
+          <p:cNvPr id="4" name="Image 0" descr="img/escut.png">    </p:cNvPr>
+          <p:cNvPicPr>
+            <a:picLocks noChangeAspect="1"/>
+          </p:cNvPicPr>
+          <p:nvPr/>
+        </p:nvPicPr>
+        <p:blipFill>
+          <a:blip r:embed="rId2"/>
+          <a:stretch>
+            <a:fillRect/>
+          </a:stretch>
+        </p:blipFill>
+        <p:spPr>
+          <a:xfrm>
+            <a:off x="2505212" y="3662680"/>
+            <a:ext cx="475976" cy="650240"/>
+          </a:xfrm>
+          <a:prstGeom prst="rect">
+            <a:avLst/>
+          </a:prstGeom>
+        </p:spPr>
+      </p:pic>
+      <p:sp>
+        <p:nvSpPr>
+          <p:cNvPr id="5" name="Text 2"/>
+          <p:cNvSpPr/>
+          <p:nvPr/>
+        </p:nvSpPr>
+        <p:spPr>
+          <a:xfrm>
+            <a:off x="3098800" y="3505200"/>
+            <a:ext cx="2235200" cy="965200"/>
+          </a:xfrm>
+          <a:prstGeom prst="rect">
+            <a:avLst/>
+          </a:prstGeom>
+          <a:noFill/>
+          <a:ln/>
+        </p:spPr>
+        <p:txBody>
+          <a:bodyPr wrap="square" lIns="0" tIns="0" rIns="0" bIns="0" rtlCol="0" anchor="ctr"/>
+          <a:lstStyle/>
+          <a:p>
+            <a:pPr algn="l" indent="0" marL="0">
+              <a:buNone/>
+            </a:pPr>
+            <a:r>
+              <a:rPr lang="en-US" sz="2880" b="1" spc="300" kern="0" dirty="0">
+                <a:solidFill>
+                  <a:srgbClr val="C7A24C"/>
+                </a:solidFill>
+                <a:latin typeface="Georgia" pitchFamily="34" charset="0"/>
+                <a:ea typeface="Georgia" pitchFamily="34" charset="-122"/>
+                <a:cs typeface="Georgia" pitchFamily="34" charset="-120"/>
+              </a:rPr>
+              <a:t>ÉS BARNA</a:t>
+            </a:r>
+            <a:endParaRPr lang="en-US" sz="2880" dirty="0"/>
+          </a:p>
+        </p:txBody>
+      </p:sp>
+      <p:sp>
+        <p:nvSpPr>
+          <p:cNvPr id="6" name="Text 3"/>
+          <p:cNvSpPr/>
+          <p:nvPr/>
+        </p:nvSpPr>
+        <p:spPr>
+          <a:xfrm>
+            <a:off x="355600" y="6350000"/>
+            <a:ext cx="4775200" cy="243840"/>
+          </a:xfrm>
+          <a:prstGeom prst="rect">
+            <a:avLst/>
+          </a:prstGeom>
+          <a:noFill/>
+          <a:ln/>
+        </p:spPr>
+        <p:txBody>
+          <a:bodyPr wrap="square" lIns="0" tIns="0" rIns="0" bIns="0" rtlCol="0" anchor="ctr"/>
+          <a:lstStyle/>
+          <a:p>
+            <a:pPr algn="ctr" indent="0" marL="0">
+              <a:buNone/>
+            </a:pPr>
+            <a:r>
+              <a:rPr lang="en-US" sz="960" b="1" spc="400" kern="0" dirty="0">
+                <a:solidFill>
+                  <a:srgbClr val="8A6E33"/>
+                </a:solidFill>
+                <a:latin typeface="Montserrat" pitchFamily="34" charset="0"/>
+                <a:ea typeface="Montserrat" pitchFamily="34" charset="-122"/>
+                <a:cs typeface="Montserrat" pitchFamily="34" charset="-120"/>
+              </a:rPr>
+              <a:t>BENVINGUT AL CLOT · NOU FITXATGE · TEMPORADA 26·27</a:t>
             </a:r>
             <a:endParaRPr lang="en-US" sz="960" dirty="0"/>
           </a:p>

</xml_diff>